<commit_message>
Polish assistant UI and add Service Mesh video case
</commit_message>
<xml_diff>
--- a/docs/cases/ai-security-evolution-content-scenario/ai-security-evolution-scenario.pptx
+++ b/docs/cases/ai-security-evolution-content-scenario/ai-security-evolution-scenario.pptx
@@ -10,7 +10,6 @@
     <p:sldId id="258" r:id="rId9"/>
     <p:sldId id="259" r:id="rId10"/>
     <p:sldId id="260" r:id="rId11"/>
-    <p:sldId id="261" r:id="rId12"/>
   </p:sldIdLst>
   <p:sldSz cx="12191695" cy="6858000" type="screen4x3"/>
   <p:notesSz cx="6858000" cy="9144000"/>
@@ -3109,8 +3108,8 @@
         </p:nvSpPr>
         <p:spPr>
           <a:xfrm>
-            <a:off x="594360" y="384048"/>
-            <a:ext cx="10972800" cy="685800"/>
+            <a:off x="548640" y="320040"/>
+            <a:ext cx="11064240" cy="731520"/>
           </a:xfrm>
           <a:prstGeom prst="rect">
             <a:avLst/>
@@ -3123,15 +3122,30 @@
           </a:bodyPr>
           <a:lstStyle/>
           <a:p>
+            <a:r>
+              <a:rPr sz="2800" b="1">
+                <a:solidFill>
+                  <a:srgbClr val="0F172A"/>
+                </a:solidFill>
+                <a:latin typeface="PingFang SC"/>
+              </a:rPr>
+              <a:t>从单机权限到 AI 模型与知识保护</a:t>
+            </a:r>
+          </a:p>
+          <a:p>
             <a:pPr>
-              <a:defRPr sz="3000" b="1">
-                <a:solidFill>
-                  <a:srgbClr val="181F2A"/>
-                </a:solidFill>
-              </a:defRPr>
+              <a:spcBef>
+                <a:spcPts val="400"/>
+              </a:spcBef>
             </a:pPr>
             <a:r>
-              <a:t>从单机权限到 AI 模型与知识保护</a:t>
+              <a:rPr sz="1200">
+                <a:solidFill>
+                  <a:srgbClr val="475569"/>
+                </a:solidFill>
+                <a:latin typeface="PingFang SC"/>
+              </a:rPr>
+              <a:t>安全边界正在从机器、网络和应用，迁移到身份、知识和行动主体</a:t>
             </a:r>
           </a:p>
         </p:txBody>
@@ -3144,8 +3158,8 @@
         </p:nvSpPr>
         <p:spPr>
           <a:xfrm>
-            <a:off x="621792" y="1024128"/>
-            <a:ext cx="10789920" cy="384048"/>
+            <a:off x="685800" y="1280160"/>
+            <a:ext cx="10789920" cy="4297680"/>
           </a:xfrm>
           <a:prstGeom prst="rect">
             <a:avLst/>
@@ -3153,304 +3167,60 @@
           <a:noFill/>
         </p:spPr>
         <p:txBody>
-          <a:bodyPr wrap="none">
+          <a:bodyPr wrap="square">
             <a:spAutoFit/>
           </a:bodyPr>
           <a:lstStyle/>
           <a:p>
             <a:pPr>
-              <a:defRPr sz="1400">
-                <a:solidFill>
-                  <a:srgbClr val="525C6C"/>
-                </a:solidFill>
-              </a:defRPr>
+              <a:spcAft>
+                <a:spcPts val="1600"/>
+              </a:spcAft>
             </a:pPr>
             <a:r>
-              <a:t>安全边界正在从“保护入口”迁移到“治理智能体行为”</a:t>
-            </a:r>
-          </a:p>
-        </p:txBody>
-      </p:sp>
-      <p:sp>
-        <p:nvSpPr>
-          <p:cNvPr id="4" name="Rounded Rectangle 3"/>
-          <p:cNvSpPr/>
+              <a:rPr sz="2000">
+                <a:solidFill>
+                  <a:srgbClr val="0F172A"/>
+                </a:solidFill>
+                <a:latin typeface="PingFang SC"/>
+              </a:rPr>
+              <a:t>单机权限 -&gt; 网络边界 -&gt; Web 安全 -&gt; 云身份 -&gt; Zero Trust -&gt; AI Agent 身份 -&gt; AI 模型与知识保护</a:t>
+            </a:r>
+          </a:p>
+          <a:p>
+            <a:r>
+              <a:rPr sz="1600">
+                <a:solidFill>
+                  <a:srgbClr val="0F172A"/>
+                </a:solidFill>
+                <a:latin typeface="PingFang SC"/>
+              </a:rPr>
+              <a:t/>
+            </a:r>
+          </a:p>
+          <a:p>
+            <a:r>
+              <a:rPr sz="1600">
+                <a:solidFill>
+                  <a:srgbClr val="0F172A"/>
+                </a:solidFill>
+                <a:latin typeface="PingFang SC"/>
+              </a:rPr>
+              <a:t>这页用一张表说明：安全边界不再只围绕系统入口，而是围绕谁在什么上下文里，携带什么知识，代表谁执行什么动作。</a:t>
+            </a:r>
+          </a:p>
+        </p:txBody>
+      </p:sp>
+      <p:sp>
+        <p:nvSpPr>
+          <p:cNvPr id="4" name="TextBox 3"/>
+          <p:cNvSpPr txBox="1"/>
           <p:nvPr/>
         </p:nvSpPr>
         <p:spPr>
           <a:xfrm>
-            <a:off x="658368" y="1965960"/>
-            <a:ext cx="1920240" cy="438912"/>
-          </a:xfrm>
-          <a:prstGeom prst="roundRect">
-            <a:avLst/>
-          </a:prstGeom>
-          <a:solidFill>
-            <a:srgbClr val="2463EB"/>
-          </a:solidFill>
-          <a:ln>
-            <a:solidFill>
-              <a:srgbClr val="2463EB"/>
-            </a:solidFill>
-          </a:ln>
-        </p:spPr>
-        <p:style>
-          <a:lnRef idx="1">
-            <a:schemeClr val="accent1"/>
-          </a:lnRef>
-          <a:fillRef idx="3">
-            <a:schemeClr val="accent1"/>
-          </a:fillRef>
-          <a:effectRef idx="2">
-            <a:schemeClr val="accent1"/>
-          </a:effectRef>
-          <a:fontRef idx="minor">
-            <a:schemeClr val="lt1"/>
-          </a:fontRef>
-        </p:style>
-        <p:txBody>
-          <a:bodyPr rtlCol="0" anchor="ctr"/>
-          <a:lstStyle/>
-          <a:p>
-            <a:pPr algn="ctr">
-              <a:defRPr sz="1300" b="1">
-                <a:solidFill>
-                  <a:srgbClr val="FFFFFF"/>
-                </a:solidFill>
-              </a:defRPr>
-            </a:pPr>
-            <a:r>
-              <a:t>单机权限</a:t>
-            </a:r>
-          </a:p>
-        </p:txBody>
-      </p:sp>
-      <p:sp>
-        <p:nvSpPr>
-          <p:cNvPr id="5" name="Rounded Rectangle 4"/>
-          <p:cNvSpPr/>
-          <p:nvPr/>
-        </p:nvSpPr>
-        <p:spPr>
-          <a:xfrm>
-            <a:off x="2743200" y="1965960"/>
-            <a:ext cx="1920240" cy="438912"/>
-          </a:xfrm>
-          <a:prstGeom prst="roundRect">
-            <a:avLst/>
-          </a:prstGeom>
-          <a:solidFill>
-            <a:srgbClr val="0D9488"/>
-          </a:solidFill>
-          <a:ln>
-            <a:solidFill>
-              <a:srgbClr val="0D9488"/>
-            </a:solidFill>
-          </a:ln>
-        </p:spPr>
-        <p:style>
-          <a:lnRef idx="1">
-            <a:schemeClr val="accent1"/>
-          </a:lnRef>
-          <a:fillRef idx="3">
-            <a:schemeClr val="accent1"/>
-          </a:fillRef>
-          <a:effectRef idx="2">
-            <a:schemeClr val="accent1"/>
-          </a:effectRef>
-          <a:fontRef idx="minor">
-            <a:schemeClr val="lt1"/>
-          </a:fontRef>
-        </p:style>
-        <p:txBody>
-          <a:bodyPr rtlCol="0" anchor="ctr"/>
-          <a:lstStyle/>
-          <a:p>
-            <a:pPr algn="ctr">
-              <a:defRPr sz="1300" b="1">
-                <a:solidFill>
-                  <a:srgbClr val="FFFFFF"/>
-                </a:solidFill>
-              </a:defRPr>
-            </a:pPr>
-            <a:r>
-              <a:t>网络边界</a:t>
-            </a:r>
-          </a:p>
-        </p:txBody>
-      </p:sp>
-      <p:sp>
-        <p:nvSpPr>
-          <p:cNvPr id="6" name="Rounded Rectangle 5"/>
-          <p:cNvSpPr/>
-          <p:nvPr/>
-        </p:nvSpPr>
-        <p:spPr>
-          <a:xfrm>
-            <a:off x="4828032" y="1965960"/>
-            <a:ext cx="1920240" cy="438912"/>
-          </a:xfrm>
-          <a:prstGeom prst="roundRect">
-            <a:avLst/>
-          </a:prstGeom>
-          <a:solidFill>
-            <a:srgbClr val="EA580C"/>
-          </a:solidFill>
-          <a:ln>
-            <a:solidFill>
-              <a:srgbClr val="EA580C"/>
-            </a:solidFill>
-          </a:ln>
-        </p:spPr>
-        <p:style>
-          <a:lnRef idx="1">
-            <a:schemeClr val="accent1"/>
-          </a:lnRef>
-          <a:fillRef idx="3">
-            <a:schemeClr val="accent1"/>
-          </a:fillRef>
-          <a:effectRef idx="2">
-            <a:schemeClr val="accent1"/>
-          </a:effectRef>
-          <a:fontRef idx="minor">
-            <a:schemeClr val="lt1"/>
-          </a:fontRef>
-        </p:style>
-        <p:txBody>
-          <a:bodyPr rtlCol="0" anchor="ctr"/>
-          <a:lstStyle/>
-          <a:p>
-            <a:pPr algn="ctr">
-              <a:defRPr sz="1300" b="1">
-                <a:solidFill>
-                  <a:srgbClr val="FFFFFF"/>
-                </a:solidFill>
-              </a:defRPr>
-            </a:pPr>
-            <a:r>
-              <a:t>云身份</a:t>
-            </a:r>
-          </a:p>
-        </p:txBody>
-      </p:sp>
-      <p:sp>
-        <p:nvSpPr>
-          <p:cNvPr id="7" name="Rounded Rectangle 6"/>
-          <p:cNvSpPr/>
-          <p:nvPr/>
-        </p:nvSpPr>
-        <p:spPr>
-          <a:xfrm>
-            <a:off x="6912864" y="1965960"/>
-            <a:ext cx="1920240" cy="438912"/>
-          </a:xfrm>
-          <a:prstGeom prst="roundRect">
-            <a:avLst/>
-          </a:prstGeom>
-          <a:solidFill>
-            <a:srgbClr val="2463EB"/>
-          </a:solidFill>
-          <a:ln>
-            <a:solidFill>
-              <a:srgbClr val="2463EB"/>
-            </a:solidFill>
-          </a:ln>
-        </p:spPr>
-        <p:style>
-          <a:lnRef idx="1">
-            <a:schemeClr val="accent1"/>
-          </a:lnRef>
-          <a:fillRef idx="3">
-            <a:schemeClr val="accent1"/>
-          </a:fillRef>
-          <a:effectRef idx="2">
-            <a:schemeClr val="accent1"/>
-          </a:effectRef>
-          <a:fontRef idx="minor">
-            <a:schemeClr val="lt1"/>
-          </a:fontRef>
-        </p:style>
-        <p:txBody>
-          <a:bodyPr rtlCol="0" anchor="ctr"/>
-          <a:lstStyle/>
-          <a:p>
-            <a:pPr algn="ctr">
-              <a:defRPr sz="1300" b="1">
-                <a:solidFill>
-                  <a:srgbClr val="FFFFFF"/>
-                </a:solidFill>
-              </a:defRPr>
-            </a:pPr>
-            <a:r>
-              <a:t>Agent 身份</a:t>
-            </a:r>
-          </a:p>
-        </p:txBody>
-      </p:sp>
-      <p:sp>
-        <p:nvSpPr>
-          <p:cNvPr id="8" name="Rounded Rectangle 7"/>
-          <p:cNvSpPr/>
-          <p:nvPr/>
-        </p:nvSpPr>
-        <p:spPr>
-          <a:xfrm>
-            <a:off x="8997696" y="1965960"/>
-            <a:ext cx="2468880" cy="438912"/>
-          </a:xfrm>
-          <a:prstGeom prst="roundRect">
-            <a:avLst/>
-          </a:prstGeom>
-          <a:solidFill>
-            <a:srgbClr val="0D9488"/>
-          </a:solidFill>
-          <a:ln>
-            <a:solidFill>
-              <a:srgbClr val="0D9488"/>
-            </a:solidFill>
-          </a:ln>
-        </p:spPr>
-        <p:style>
-          <a:lnRef idx="1">
-            <a:schemeClr val="accent1"/>
-          </a:lnRef>
-          <a:fillRef idx="3">
-            <a:schemeClr val="accent1"/>
-          </a:fillRef>
-          <a:effectRef idx="2">
-            <a:schemeClr val="accent1"/>
-          </a:effectRef>
-          <a:fontRef idx="minor">
-            <a:schemeClr val="lt1"/>
-          </a:fontRef>
-        </p:style>
-        <p:txBody>
-          <a:bodyPr rtlCol="0" anchor="ctr"/>
-          <a:lstStyle/>
-          <a:p>
-            <a:pPr algn="ctr">
-              <a:defRPr sz="1300" b="1">
-                <a:solidFill>
-                  <a:srgbClr val="FFFFFF"/>
-                </a:solidFill>
-              </a:defRPr>
-            </a:pPr>
-            <a:r>
-              <a:t>模型与知识保护</a:t>
-            </a:r>
-          </a:p>
-        </p:txBody>
-      </p:sp>
-      <p:sp>
-        <p:nvSpPr>
-          <p:cNvPr id="9" name="TextBox 8"/>
-          <p:cNvSpPr txBox="1"/>
-          <p:nvPr/>
-        </p:nvSpPr>
-        <p:spPr>
-          <a:xfrm>
-            <a:off x="658368" y="2971800"/>
-            <a:ext cx="10789920" cy="2011680"/>
+            <a:off x="548640" y="6400800"/>
+            <a:ext cx="11064240" cy="228600"/>
           </a:xfrm>
           <a:prstGeom prst="rect">
             <a:avLst/>
@@ -3458,88 +3228,19 @@
           <a:noFill/>
         </p:spPr>
         <p:txBody>
-          <a:bodyPr wrap="square">
-            <a:spAutoFit/>
-          </a:bodyPr>
-          <a:lstStyle/>
-          <a:p>
-            <a:pPr>
-              <a:spcAft>
-                <a:spcPts val="800"/>
-              </a:spcAft>
-              <a:defRPr sz="2200">
-                <a:solidFill>
-                  <a:srgbClr val="181F2A"/>
-                </a:solidFill>
-              </a:defRPr>
-            </a:pPr>
-            <a:r>
-              <a:t>计算形态变化，会推动安全边界重新定义。</a:t>
-            </a:r>
-          </a:p>
-          <a:p>
-            <a:pPr>
-              <a:spcAft>
-                <a:spcPts val="800"/>
-              </a:spcAft>
-              <a:defRPr sz="2200">
-                <a:solidFill>
-                  <a:srgbClr val="181F2A"/>
-                </a:solidFill>
-              </a:defRPr>
-            </a:pPr>
-            <a:r>
-              <a:t>AI Agent 不只是对话入口，而是能携带知识、调用工具、执行任务的新主体。</a:t>
-            </a:r>
-          </a:p>
-          <a:p>
-            <a:pPr>
-              <a:spcAft>
-                <a:spcPts val="800"/>
-              </a:spcAft>
-              <a:defRPr sz="2200">
-                <a:solidFill>
-                  <a:srgbClr val="181F2A"/>
-                </a:solidFill>
-              </a:defRPr>
-            </a:pPr>
-            <a:r>
-              <a:t>当下的核心问题：谁能携带什么知识，以什么身份，替谁执行什么动作。</a:t>
-            </a:r>
-          </a:p>
-        </p:txBody>
-      </p:sp>
-      <p:sp>
-        <p:nvSpPr>
-          <p:cNvPr id="10" name="TextBox 9"/>
-          <p:cNvSpPr txBox="1"/>
-          <p:nvPr/>
-        </p:nvSpPr>
-        <p:spPr>
-          <a:xfrm>
-            <a:off x="594360" y="6446520"/>
-            <a:ext cx="10972800" cy="228600"/>
-          </a:xfrm>
-          <a:prstGeom prst="rect">
-            <a:avLst/>
-          </a:prstGeom>
-          <a:noFill/>
-        </p:spPr>
-        <p:txBody>
           <a:bodyPr wrap="none">
             <a:spAutoFit/>
           </a:bodyPr>
           <a:lstStyle/>
           <a:p>
-            <a:pPr>
-              <a:defRPr sz="900">
-                <a:solidFill>
-                  <a:srgbClr val="525C6C"/>
-                </a:solidFill>
-              </a:defRPr>
-            </a:pPr>
-            <a:r>
-              <a:t>XWorkmate App 场景测试用例 · AI 安全演进 · 1</a:t>
+            <a:pPr algn="r"/>
+            <a:r>
+              <a:rPr sz="900">
+                <a:solidFill>
+                  <a:srgbClr val="475569"/>
+                </a:solidFill>
+              </a:rPr>
+              <a:t>AI security evolution</a:t>
             </a:r>
           </a:p>
         </p:txBody>
@@ -3578,8 +3279,8 @@
         </p:nvSpPr>
         <p:spPr>
           <a:xfrm>
-            <a:off x="594360" y="384048"/>
-            <a:ext cx="10972800" cy="685800"/>
+            <a:off x="548640" y="320040"/>
+            <a:ext cx="11064240" cy="731520"/>
           </a:xfrm>
           <a:prstGeom prst="rect">
             <a:avLst/>
@@ -3592,65 +3293,29 @@
           </a:bodyPr>
           <a:lstStyle/>
           <a:p>
-            <a:pPr>
-              <a:defRPr sz="3000" b="1">
-                <a:solidFill>
-                  <a:srgbClr val="181F2A"/>
-                </a:solidFill>
-              </a:defRPr>
-            </a:pPr>
-            <a:r>
-              <a:t>安全演进对照表</a:t>
-            </a:r>
-          </a:p>
-        </p:txBody>
-      </p:sp>
-      <p:sp>
-        <p:nvSpPr>
-          <p:cNvPr id="3" name="TextBox 2"/>
-          <p:cNvSpPr txBox="1"/>
-          <p:nvPr/>
-        </p:nvSpPr>
-        <p:spPr>
-          <a:xfrm>
-            <a:off x="621792" y="1024128"/>
-            <a:ext cx="10789920" cy="384048"/>
-          </a:xfrm>
-          <a:prstGeom prst="rect">
-            <a:avLst/>
-          </a:prstGeom>
-          <a:noFill/>
-        </p:spPr>
-        <p:txBody>
-          <a:bodyPr wrap="none">
-            <a:spAutoFit/>
-          </a:bodyPr>
-          <a:lstStyle/>
-          <a:p>
-            <a:pPr>
-              <a:defRPr sz="1400">
-                <a:solidFill>
-                  <a:srgbClr val="525C6C"/>
-                </a:solidFill>
-              </a:defRPr>
-            </a:pPr>
-            <a:r>
-              <a:t>左侧是路径，右侧是当下需要落到架构里的判断</a:t>
+            <a:r>
+              <a:rPr sz="2800" b="1">
+                <a:solidFill>
+                  <a:srgbClr val="0F172A"/>
+                </a:solidFill>
+                <a:latin typeface="PingFang SC"/>
+              </a:rPr>
+              <a:t>一张表看安全边界的演进</a:t>
             </a:r>
           </a:p>
         </p:txBody>
       </p:sp>
       <p:graphicFrame>
         <p:nvGraphicFramePr>
-          <p:cNvPr id="4" name="Table 3"/>
+          <p:cNvPr id="3" name="Table 2"/>
           <p:cNvGraphicFramePr>
             <a:graphicFrameLocks noGrp="1"/>
           </p:cNvGraphicFramePr>
           <p:nvPr/>
         </p:nvGraphicFramePr>
         <p:xfrm>
-          <a:off x="640080" y="1508760"/>
-          <a:ext cx="10972800" cy="4434840"/>
+          <a:off x="594360" y="1143000"/>
+          <a:ext cx="11018520" cy="5166360"/>
         </p:xfrm>
         <a:graphic>
           <a:graphicData uri="http://schemas.openxmlformats.org/drawingml/2006/table">
@@ -3659,391 +3324,311 @@
                 <a:tableStyleId>{5C22544A-7EE6-4342-B048-85BDC9FD1C3A}</a:tableStyleId>
               </a:tblPr>
               <a:tblGrid>
-                <a:gridCol w="2743200"/>
-                <a:gridCol w="8229600"/>
+                <a:gridCol w="2011680"/>
+                <a:gridCol w="9006840"/>
               </a:tblGrid>
-              <a:tr h="554355">
+              <a:tr h="645795">
                 <a:tc>
                   <a:txBody>
                     <a:bodyPr/>
                     <a:lstStyle/>
                     <a:p>
-                      <a:pPr>
-                        <a:defRPr b="1" sz="1400">
+                      <a:r>
+                        <a:rPr b="1" sz="1400">
                           <a:solidFill>
-                            <a:srgbClr val="FFFFFF"/>
+                            <a:srgbClr val="0F172A"/>
                           </a:solidFill>
-                        </a:defRPr>
-                      </a:pPr>
-                      <a:r>
+                          <a:latin typeface="PingFang SC"/>
+                        </a:rPr>
                         <a:t>演进路径</a:t>
                       </a:r>
                     </a:p>
                   </a:txBody>
-                  <a:tcPr>
-                    <a:solidFill>
-                      <a:srgbClr val="181F2A"/>
-                    </a:solidFill>
-                  </a:tcPr>
+                  <a:tcPr/>
                 </a:tc>
                 <a:tc>
                   <a:txBody>
                     <a:bodyPr/>
                     <a:lstStyle/>
                     <a:p>
-                      <a:pPr>
-                        <a:defRPr b="1" sz="1400">
+                      <a:r>
+                        <a:rPr b="1" sz="1400">
                           <a:solidFill>
-                            <a:srgbClr val="FFFFFF"/>
+                            <a:srgbClr val="0F172A"/>
                           </a:solidFill>
-                        </a:defRPr>
-                      </a:pPr>
-                      <a:r>
-                        <a:t>当下判断</a:t>
+                          <a:latin typeface="PingFang SC"/>
+                        </a:rPr>
+                        <a:t>当下</a:t>
                       </a:r>
                     </a:p>
                   </a:txBody>
-                  <a:tcPr>
-                    <a:solidFill>
-                      <a:srgbClr val="181F2A"/>
-                    </a:solidFill>
-                  </a:tcPr>
+                  <a:tcPr/>
                 </a:tc>
               </a:tr>
-              <a:tr h="554355">
+              <a:tr h="645795">
                 <a:tc>
                   <a:txBody>
                     <a:bodyPr/>
                     <a:lstStyle/>
                     <a:p>
-                      <a:pPr>
-                        <a:defRPr sz="1200" b="1">
+                      <a:r>
+                        <a:rPr sz="1200">
                           <a:solidFill>
-                            <a:srgbClr val="181F2A"/>
+                            <a:srgbClr val="0F172A"/>
                           </a:solidFill>
-                        </a:defRPr>
-                      </a:pPr>
-                      <a:r>
+                          <a:latin typeface="PingFang SC"/>
+                        </a:rPr>
                         <a:t>单机权限</a:t>
                       </a:r>
                     </a:p>
                   </a:txBody>
-                  <a:tcPr>
-                    <a:solidFill>
-                      <a:srgbClr val="FFFFFF"/>
-                    </a:solidFill>
-                  </a:tcPr>
+                  <a:tcPr/>
                 </a:tc>
                 <a:tc>
                   <a:txBody>
                     <a:bodyPr/>
                     <a:lstStyle/>
                     <a:p>
-                      <a:pPr>
-                        <a:defRPr sz="1200">
+                      <a:r>
+                        <a:rPr sz="1200">
                           <a:solidFill>
-                            <a:srgbClr val="525C6C"/>
+                            <a:srgbClr val="0F172A"/>
                           </a:solidFill>
-                        </a:defRPr>
-                      </a:pPr>
-                      <a:r>
-                        <a:t>终端只是入口，风险进入身份、数据和任务链路。</a:t>
+                          <a:latin typeface="PingFang SC"/>
+                        </a:rPr>
+                        <a:t>权限不再只发生在单机，终端只是身份、数据和任务链路的入口。</a:t>
                       </a:r>
                     </a:p>
                   </a:txBody>
-                  <a:tcPr>
-                    <a:solidFill>
-                      <a:srgbClr val="FFFFFF"/>
-                    </a:solidFill>
-                  </a:tcPr>
+                  <a:tcPr/>
                 </a:tc>
               </a:tr>
-              <a:tr h="554355">
+              <a:tr h="645795">
                 <a:tc>
                   <a:txBody>
                     <a:bodyPr/>
                     <a:lstStyle/>
                     <a:p>
-                      <a:pPr>
-                        <a:defRPr sz="1200" b="1">
+                      <a:r>
+                        <a:rPr sz="1200">
                           <a:solidFill>
-                            <a:srgbClr val="181F2A"/>
+                            <a:srgbClr val="0F172A"/>
                           </a:solidFill>
-                        </a:defRPr>
-                      </a:pPr>
-                      <a:r>
+                          <a:latin typeface="PingFang SC"/>
+                        </a:rPr>
                         <a:t>网络边界</a:t>
                       </a:r>
                     </a:p>
                   </a:txBody>
-                  <a:tcPr>
-                    <a:solidFill>
-                      <a:srgbClr val="FFFFFF"/>
-                    </a:solidFill>
-                  </a:tcPr>
+                  <a:tcPr/>
                 </a:tc>
                 <a:tc>
                   <a:txBody>
                     <a:bodyPr/>
                     <a:lstStyle/>
                     <a:p>
-                      <a:pPr>
-                        <a:defRPr sz="1200">
+                      <a:r>
+                        <a:rPr sz="1200">
                           <a:solidFill>
-                            <a:srgbClr val="525C6C"/>
+                            <a:srgbClr val="0F172A"/>
                           </a:solidFill>
-                        </a:defRPr>
-                      </a:pPr>
-                      <a:r>
-                        <a:t>边界变成 API、设备、身份、供应链和运行时组合面。</a:t>
+                          <a:latin typeface="PingFang SC"/>
+                        </a:rPr>
+                        <a:t>边界从机房防火墙变成 API、身份、设备、供应链和运行时的组合面。</a:t>
                       </a:r>
                     </a:p>
                   </a:txBody>
-                  <a:tcPr>
-                    <a:solidFill>
-                      <a:srgbClr val="FFFFFF"/>
-                    </a:solidFill>
-                  </a:tcPr>
+                  <a:tcPr/>
                 </a:tc>
               </a:tr>
-              <a:tr h="554355">
+              <a:tr h="645795">
                 <a:tc>
                   <a:txBody>
                     <a:bodyPr/>
                     <a:lstStyle/>
                     <a:p>
-                      <a:pPr>
-                        <a:defRPr sz="1200" b="1">
+                      <a:r>
+                        <a:rPr sz="1200">
                           <a:solidFill>
-                            <a:srgbClr val="181F2A"/>
+                            <a:srgbClr val="0F172A"/>
                           </a:solidFill>
-                        </a:defRPr>
-                      </a:pPr>
-                      <a:r>
+                          <a:latin typeface="PingFang SC"/>
+                        </a:rPr>
                         <a:t>Web 安全</a:t>
                       </a:r>
                     </a:p>
                   </a:txBody>
-                  <a:tcPr>
-                    <a:solidFill>
-                      <a:srgbClr val="FFFFFF"/>
-                    </a:solidFill>
-                  </a:tcPr>
+                  <a:tcPr/>
                 </a:tc>
                 <a:tc>
                   <a:txBody>
                     <a:bodyPr/>
                     <a:lstStyle/>
                     <a:p>
-                      <a:pPr>
-                        <a:defRPr sz="1200">
+                      <a:r>
+                        <a:rPr sz="1200">
                           <a:solidFill>
-                            <a:srgbClr val="525C6C"/>
+                            <a:srgbClr val="0F172A"/>
                           </a:solidFill>
-                        </a:defRPr>
-                      </a:pPr>
-                      <a:r>
-                        <a:t>从页面漏洞扩展到业务流、插件和自动化调用。</a:t>
+                          <a:latin typeface="PingFang SC"/>
+                        </a:rPr>
+                        <a:t>Web 风险仍在，但主战场从页面漏洞扩展到业务流、插件、自动化调用和数据泄露。</a:t>
                       </a:r>
                     </a:p>
                   </a:txBody>
-                  <a:tcPr>
-                    <a:solidFill>
-                      <a:srgbClr val="FFFFFF"/>
-                    </a:solidFill>
-                  </a:tcPr>
+                  <a:tcPr/>
                 </a:tc>
               </a:tr>
-              <a:tr h="554355">
+              <a:tr h="645795">
                 <a:tc>
                   <a:txBody>
                     <a:bodyPr/>
                     <a:lstStyle/>
                     <a:p>
-                      <a:pPr>
-                        <a:defRPr sz="1200" b="1">
+                      <a:r>
+                        <a:rPr sz="1200">
                           <a:solidFill>
-                            <a:srgbClr val="181F2A"/>
+                            <a:srgbClr val="0F172A"/>
                           </a:solidFill>
-                        </a:defRPr>
-                      </a:pPr>
-                      <a:r>
+                          <a:latin typeface="PingFang SC"/>
+                        </a:rPr>
                         <a:t>云身份</a:t>
                       </a:r>
                     </a:p>
                   </a:txBody>
-                  <a:tcPr>
-                    <a:solidFill>
-                      <a:srgbClr val="FFFFFF"/>
-                    </a:solidFill>
-                  </a:tcPr>
+                  <a:tcPr/>
                 </a:tc>
                 <a:tc>
                   <a:txBody>
                     <a:bodyPr/>
                     <a:lstStyle/>
                     <a:p>
-                      <a:pPr>
-                        <a:defRPr sz="1200">
+                      <a:r>
+                        <a:rPr sz="1200">
                           <a:solidFill>
-                            <a:srgbClr val="525C6C"/>
+                            <a:srgbClr val="0F172A"/>
                           </a:solidFill>
-                        </a:defRPr>
-                      </a:pPr>
-                      <a:r>
-                        <a:t>IAM 成为控制平面，权限漂移和密钥暴露高发。</a:t>
+                          <a:latin typeface="PingFang SC"/>
+                        </a:rPr>
+                        <a:t>云身份成为默认控制平面，权限漂移、密钥暴露和跨账号访问是主要风险。</a:t>
                       </a:r>
                     </a:p>
                   </a:txBody>
-                  <a:tcPr>
-                    <a:solidFill>
-                      <a:srgbClr val="FFFFFF"/>
-                    </a:solidFill>
-                  </a:tcPr>
+                  <a:tcPr/>
                 </a:tc>
               </a:tr>
-              <a:tr h="554355">
+              <a:tr h="645795">
                 <a:tc>
                   <a:txBody>
                     <a:bodyPr/>
                     <a:lstStyle/>
                     <a:p>
-                      <a:pPr>
-                        <a:defRPr sz="1200" b="1">
+                      <a:r>
+                        <a:rPr sz="1200">
                           <a:solidFill>
-                            <a:srgbClr val="181F2A"/>
+                            <a:srgbClr val="0F172A"/>
                           </a:solidFill>
-                        </a:defRPr>
-                      </a:pPr>
-                      <a:r>
+                          <a:latin typeface="PingFang SC"/>
+                        </a:rPr>
                         <a:t>Zero Trust</a:t>
                       </a:r>
                     </a:p>
                   </a:txBody>
-                  <a:tcPr>
-                    <a:solidFill>
-                      <a:srgbClr val="FFFFFF"/>
-                    </a:solidFill>
-                  </a:tcPr>
+                  <a:tcPr/>
                 </a:tc>
                 <a:tc>
                   <a:txBody>
                     <a:bodyPr/>
                     <a:lstStyle/>
                     <a:p>
-                      <a:pPr>
-                        <a:defRPr sz="1200">
+                      <a:r>
+                        <a:rPr sz="1200">
                           <a:solidFill>
-                            <a:srgbClr val="525C6C"/>
+                            <a:srgbClr val="0F172A"/>
                           </a:solidFill>
-                        </a:defRPr>
-                      </a:pPr>
-                      <a:r>
-                        <a:t>持续验证、最小权限、上下文授权进入执行层。</a:t>
+                          <a:latin typeface="PingFang SC"/>
+                        </a:rPr>
+                        <a:t>Zero Trust 从口号进入执行层，核心是持续验证、最小权限和上下文决策。</a:t>
                       </a:r>
                     </a:p>
                   </a:txBody>
-                  <a:tcPr>
-                    <a:solidFill>
-                      <a:srgbClr val="FFFFFF"/>
-                    </a:solidFill>
-                  </a:tcPr>
+                  <a:tcPr/>
                 </a:tc>
               </a:tr>
-              <a:tr h="554355">
+              <a:tr h="645795">
                 <a:tc>
                   <a:txBody>
                     <a:bodyPr/>
                     <a:lstStyle/>
                     <a:p>
-                      <a:pPr>
-                        <a:defRPr sz="1200" b="1">
+                      <a:r>
+                        <a:rPr sz="1200">
                           <a:solidFill>
-                            <a:srgbClr val="181F2A"/>
+                            <a:srgbClr val="0F172A"/>
                           </a:solidFill>
-                        </a:defRPr>
-                      </a:pPr>
-                      <a:r>
+                          <a:latin typeface="PingFang SC"/>
+                        </a:rPr>
                         <a:t>AI Agent 身份</a:t>
                       </a:r>
                     </a:p>
                   </a:txBody>
-                  <a:tcPr>
-                    <a:solidFill>
-                      <a:srgbClr val="FFFFFF"/>
-                    </a:solidFill>
-                  </a:tcPr>
+                  <a:tcPr/>
                 </a:tc>
                 <a:tc>
                   <a:txBody>
                     <a:bodyPr/>
                     <a:lstStyle/>
                     <a:p>
-                      <a:pPr>
-                        <a:defRPr sz="1200">
+                      <a:r>
+                        <a:rPr sz="1200">
                           <a:solidFill>
-                            <a:srgbClr val="525C6C"/>
+                            <a:srgbClr val="0F172A"/>
                           </a:solidFill>
-                        </a:defRPr>
-                      </a:pPr>
-                      <a:r>
-                        <a:t>Agent 要有独立身份、授权边界、审计链和撤销能力。</a:t>
+                          <a:latin typeface="PingFang SC"/>
+                        </a:rPr>
+                        <a:t>Agent 开始代表人执行任务，必须有独立身份、授权边界、审计链和可撤销能力。</a:t>
                       </a:r>
                     </a:p>
                   </a:txBody>
-                  <a:tcPr>
-                    <a:solidFill>
-                      <a:srgbClr val="FFFFFF"/>
-                    </a:solidFill>
-                  </a:tcPr>
+                  <a:tcPr/>
                 </a:tc>
               </a:tr>
-              <a:tr h="554355">
+              <a:tr h="645795">
                 <a:tc>
                   <a:txBody>
                     <a:bodyPr/>
                     <a:lstStyle/>
                     <a:p>
-                      <a:pPr>
-                        <a:defRPr sz="1200" b="1">
+                      <a:r>
+                        <a:rPr sz="1200">
                           <a:solidFill>
-                            <a:srgbClr val="181F2A"/>
+                            <a:srgbClr val="0F172A"/>
                           </a:solidFill>
-                        </a:defRPr>
-                      </a:pPr>
-                      <a:r>
+                          <a:latin typeface="PingFang SC"/>
+                        </a:rPr>
                         <a:t>AI 模型与知识保护</a:t>
                       </a:r>
                     </a:p>
                   </a:txBody>
-                  <a:tcPr>
-                    <a:solidFill>
-                      <a:srgbClr val="FFFFFF"/>
-                    </a:solidFill>
-                  </a:tcPr>
+                  <a:tcPr/>
                 </a:tc>
                 <a:tc>
                   <a:txBody>
                     <a:bodyPr/>
                     <a:lstStyle/>
                     <a:p>
-                      <a:pPr>
-                        <a:defRPr sz="1200">
+                      <a:r>
+                        <a:rPr sz="1200">
                           <a:solidFill>
-                            <a:srgbClr val="525C6C"/>
+                            <a:srgbClr val="0F172A"/>
                           </a:solidFill>
-                        </a:defRPr>
-                      </a:pPr>
-                      <a:r>
-                        <a:t>模型、提示词、RAG、工具记录和语料成为资产边界。</a:t>
+                          <a:latin typeface="PingFang SC"/>
+                        </a:rPr>
+                        <a:t>模型、提示词、RAG 知识库、工具调用记录和业务语料共同成为新资产边界。</a:t>
                       </a:r>
                     </a:p>
                   </a:txBody>
-                  <a:tcPr>
-                    <a:solidFill>
-                      <a:srgbClr val="FFFFFF"/>
-                    </a:solidFill>
-                  </a:tcPr>
+                  <a:tcPr/>
                 </a:tc>
               </a:tr>
             </a:tbl>
@@ -4052,14 +3637,14 @@
       </p:graphicFrame>
       <p:sp>
         <p:nvSpPr>
-          <p:cNvPr id="5" name="TextBox 4"/>
+          <p:cNvPr id="4" name="TextBox 3"/>
           <p:cNvSpPr txBox="1"/>
           <p:nvPr/>
         </p:nvSpPr>
         <p:spPr>
           <a:xfrm>
-            <a:off x="594360" y="6446520"/>
-            <a:ext cx="10972800" cy="228600"/>
+            <a:off x="548640" y="6400800"/>
+            <a:ext cx="11064240" cy="228600"/>
           </a:xfrm>
           <a:prstGeom prst="rect">
             <a:avLst/>
@@ -4072,15 +3657,14 @@
           </a:bodyPr>
           <a:lstStyle/>
           <a:p>
-            <a:pPr>
-              <a:defRPr sz="900">
-                <a:solidFill>
-                  <a:srgbClr val="525C6C"/>
-                </a:solidFill>
-              </a:defRPr>
-            </a:pPr>
-            <a:r>
-              <a:t>XWorkmate App 场景测试用例 · AI 安全演进 · 2</a:t>
+            <a:pPr algn="r"/>
+            <a:r>
+              <a:rPr sz="900">
+                <a:solidFill>
+                  <a:srgbClr val="475569"/>
+                </a:solidFill>
+              </a:rPr>
+              <a:t>Table overview</a:t>
             </a:r>
           </a:p>
         </p:txBody>
@@ -4119,8 +3703,8 @@
         </p:nvSpPr>
         <p:spPr>
           <a:xfrm>
-            <a:off x="594360" y="384048"/>
-            <a:ext cx="10972800" cy="685800"/>
+            <a:off x="548640" y="320040"/>
+            <a:ext cx="11064240" cy="731520"/>
           </a:xfrm>
           <a:prstGeom prst="rect">
             <a:avLst/>
@@ -4133,15 +3717,14 @@
           </a:bodyPr>
           <a:lstStyle/>
           <a:p>
-            <a:pPr>
-              <a:defRPr sz="3000" b="1">
-                <a:solidFill>
-                  <a:srgbClr val="181F2A"/>
-                </a:solidFill>
-              </a:defRPr>
-            </a:pPr>
-            <a:r>
-              <a:t>主战场从入口迁移到行动链路</a:t>
+            <a:r>
+              <a:rPr sz="2800" b="1">
+                <a:solidFill>
+                  <a:srgbClr val="0F172A"/>
+                </a:solidFill>
+                <a:latin typeface="PingFang SC"/>
+              </a:rPr>
+              <a:t>现在最关键的变化</a:t>
             </a:r>
           </a:p>
         </p:txBody>
@@ -4154,8 +3737,8 @@
         </p:nvSpPr>
         <p:spPr>
           <a:xfrm>
-            <a:off x="621792" y="1024128"/>
-            <a:ext cx="10789920" cy="384048"/>
+            <a:off x="640080" y="1143000"/>
+            <a:ext cx="10789920" cy="4389120"/>
           </a:xfrm>
           <a:prstGeom prst="rect">
             <a:avLst/>
@@ -4169,82 +3752,80 @@
           <a:lstStyle/>
           <a:p>
             <a:pPr>
-              <a:defRPr sz="1400">
-                <a:solidFill>
-                  <a:srgbClr val="525C6C"/>
-                </a:solidFill>
-              </a:defRPr>
+              <a:spcAft>
+                <a:spcPts val="1400"/>
+              </a:spcAft>
             </a:pPr>
             <a:r>
-              <a:t>Agent 时代的安全问题变成连续链路治理</a:t>
-            </a:r>
-          </a:p>
-        </p:txBody>
-      </p:sp>
-      <p:sp>
-        <p:nvSpPr>
-          <p:cNvPr id="4" name="Rounded Rectangle 3"/>
-          <p:cNvSpPr/>
+              <a:rPr sz="1800">
+                <a:solidFill>
+                  <a:srgbClr val="0F172A"/>
+                </a:solidFill>
+                <a:latin typeface="PingFang SC"/>
+              </a:rPr>
+              <a:t>过去问：谁能登录机器。</a:t>
+            </a:r>
+          </a:p>
+          <a:p>
+            <a:pPr>
+              <a:spcAft>
+                <a:spcPts val="1400"/>
+              </a:spcAft>
+            </a:pPr>
+            <a:r>
+              <a:rPr sz="1800">
+                <a:solidFill>
+                  <a:srgbClr val="0F172A"/>
+                </a:solidFill>
+                <a:latin typeface="PingFang SC"/>
+              </a:rPr>
+              <a:t>后来问：谁能从网络边界进入。</a:t>
+            </a:r>
+          </a:p>
+          <a:p>
+            <a:pPr>
+              <a:spcAft>
+                <a:spcPts val="1400"/>
+              </a:spcAft>
+            </a:pPr>
+            <a:r>
+              <a:rPr sz="1800">
+                <a:solidFill>
+                  <a:srgbClr val="0F172A"/>
+                </a:solidFill>
+                <a:latin typeface="PingFang SC"/>
+              </a:rPr>
+              <a:t>再后来问：用户、设备、会话、API 是否可信。</a:t>
+            </a:r>
+          </a:p>
+          <a:p>
+            <a:pPr>
+              <a:spcAft>
+                <a:spcPts val="1400"/>
+              </a:spcAft>
+            </a:pPr>
+            <a:r>
+              <a:rPr sz="1700">
+                <a:solidFill>
+                  <a:srgbClr val="0F172A"/>
+                </a:solidFill>
+                <a:latin typeface="PingFang SC"/>
+              </a:rPr>
+              <a:t>现在问：这个 AI Agent 是谁授权的、能读什么、能做什么、出了问题能不能撤销。</a:t>
+            </a:r>
+          </a:p>
+        </p:txBody>
+      </p:sp>
+      <p:sp>
+        <p:nvSpPr>
+          <p:cNvPr id="4" name="TextBox 3"/>
+          <p:cNvSpPr txBox="1"/>
           <p:nvPr/>
         </p:nvSpPr>
         <p:spPr>
           <a:xfrm>
-            <a:off x="685800" y="1828800"/>
-            <a:ext cx="2240280" cy="502920"/>
-          </a:xfrm>
-          <a:prstGeom prst="roundRect">
-            <a:avLst/>
-          </a:prstGeom>
-          <a:solidFill>
-            <a:srgbClr val="2463EB"/>
-          </a:solidFill>
-          <a:ln>
-            <a:solidFill>
-              <a:srgbClr val="2463EB"/>
-            </a:solidFill>
-          </a:ln>
-        </p:spPr>
-        <p:style>
-          <a:lnRef idx="1">
-            <a:schemeClr val="accent1"/>
-          </a:lnRef>
-          <a:fillRef idx="3">
-            <a:schemeClr val="accent1"/>
-          </a:fillRef>
-          <a:effectRef idx="2">
-            <a:schemeClr val="accent1"/>
-          </a:effectRef>
-          <a:fontRef idx="minor">
-            <a:schemeClr val="lt1"/>
-          </a:fontRef>
-        </p:style>
-        <p:txBody>
-          <a:bodyPr rtlCol="0" anchor="ctr"/>
-          <a:lstStyle/>
-          <a:p>
-            <a:pPr algn="ctr">
-              <a:defRPr sz="1300" b="1">
-                <a:solidFill>
-                  <a:srgbClr val="FFFFFF"/>
-                </a:solidFill>
-              </a:defRPr>
-            </a:pPr>
-            <a:r>
-              <a:t>身份</a:t>
-            </a:r>
-          </a:p>
-        </p:txBody>
-      </p:sp>
-      <p:sp>
-        <p:nvSpPr>
-          <p:cNvPr id="5" name="TextBox 4"/>
-          <p:cNvSpPr txBox="1"/>
-          <p:nvPr/>
-        </p:nvSpPr>
-        <p:spPr>
-          <a:xfrm>
-            <a:off x="685800" y="2606040"/>
-            <a:ext cx="2240280" cy="1417320"/>
+            <a:off x="548640" y="6400800"/>
+            <a:ext cx="11064240" cy="228600"/>
           </a:xfrm>
           <a:prstGeom prst="rect">
             <a:avLst/>
@@ -4252,372 +3833,19 @@
           <a:noFill/>
         </p:spPr>
         <p:txBody>
-          <a:bodyPr wrap="square">
-            <a:spAutoFit/>
-          </a:bodyPr>
-          <a:lstStyle/>
-          <a:p>
-            <a:pPr>
-              <a:spcAft>
-                <a:spcPts val="800"/>
-              </a:spcAft>
-              <a:defRPr sz="1600">
-                <a:solidFill>
-                  <a:srgbClr val="181F2A"/>
-                </a:solidFill>
-              </a:defRPr>
-            </a:pPr>
-            <a:r>
-              <a:t>人、应用、Agent、工具必须可区分。</a:t>
-            </a:r>
-          </a:p>
-        </p:txBody>
-      </p:sp>
-      <p:sp>
-        <p:nvSpPr>
-          <p:cNvPr id="6" name="Rounded Rectangle 5"/>
-          <p:cNvSpPr/>
-          <p:nvPr/>
-        </p:nvSpPr>
-        <p:spPr>
-          <a:xfrm>
-            <a:off x="3474720" y="1828800"/>
-            <a:ext cx="2240280" cy="502920"/>
-          </a:xfrm>
-          <a:prstGeom prst="roundRect">
-            <a:avLst/>
-          </a:prstGeom>
-          <a:solidFill>
-            <a:srgbClr val="0D9488"/>
-          </a:solidFill>
-          <a:ln>
-            <a:solidFill>
-              <a:srgbClr val="0D9488"/>
-            </a:solidFill>
-          </a:ln>
-        </p:spPr>
-        <p:style>
-          <a:lnRef idx="1">
-            <a:schemeClr val="accent1"/>
-          </a:lnRef>
-          <a:fillRef idx="3">
-            <a:schemeClr val="accent1"/>
-          </a:fillRef>
-          <a:effectRef idx="2">
-            <a:schemeClr val="accent1"/>
-          </a:effectRef>
-          <a:fontRef idx="minor">
-            <a:schemeClr val="lt1"/>
-          </a:fontRef>
-        </p:style>
-        <p:txBody>
-          <a:bodyPr rtlCol="0" anchor="ctr"/>
-          <a:lstStyle/>
-          <a:p>
-            <a:pPr algn="ctr">
-              <a:defRPr sz="1300" b="1">
-                <a:solidFill>
-                  <a:srgbClr val="FFFFFF"/>
-                </a:solidFill>
-              </a:defRPr>
-            </a:pPr>
-            <a:r>
-              <a:t>知识</a:t>
-            </a:r>
-          </a:p>
-        </p:txBody>
-      </p:sp>
-      <p:sp>
-        <p:nvSpPr>
-          <p:cNvPr id="7" name="TextBox 6"/>
-          <p:cNvSpPr txBox="1"/>
-          <p:nvPr/>
-        </p:nvSpPr>
-        <p:spPr>
-          <a:xfrm>
-            <a:off x="3474720" y="2606040"/>
-            <a:ext cx="2240280" cy="1417320"/>
-          </a:xfrm>
-          <a:prstGeom prst="rect">
-            <a:avLst/>
-          </a:prstGeom>
-          <a:noFill/>
-        </p:spPr>
-        <p:txBody>
-          <a:bodyPr wrap="square">
-            <a:spAutoFit/>
-          </a:bodyPr>
-          <a:lstStyle/>
-          <a:p>
-            <a:pPr>
-              <a:spcAft>
-                <a:spcPts val="800"/>
-              </a:spcAft>
-              <a:defRPr sz="1600">
-                <a:solidFill>
-                  <a:srgbClr val="181F2A"/>
-                </a:solidFill>
-              </a:defRPr>
-            </a:pPr>
-            <a:r>
-              <a:t>RAG、文件、提示词按权限进入上下文。</a:t>
-            </a:r>
-          </a:p>
-        </p:txBody>
-      </p:sp>
-      <p:sp>
-        <p:nvSpPr>
-          <p:cNvPr id="8" name="Rounded Rectangle 7"/>
-          <p:cNvSpPr/>
-          <p:nvPr/>
-        </p:nvSpPr>
-        <p:spPr>
-          <a:xfrm>
-            <a:off x="6263640" y="1828800"/>
-            <a:ext cx="2240280" cy="502920"/>
-          </a:xfrm>
-          <a:prstGeom prst="roundRect">
-            <a:avLst/>
-          </a:prstGeom>
-          <a:solidFill>
-            <a:srgbClr val="EA580C"/>
-          </a:solidFill>
-          <a:ln>
-            <a:solidFill>
-              <a:srgbClr val="EA580C"/>
-            </a:solidFill>
-          </a:ln>
-        </p:spPr>
-        <p:style>
-          <a:lnRef idx="1">
-            <a:schemeClr val="accent1"/>
-          </a:lnRef>
-          <a:fillRef idx="3">
-            <a:schemeClr val="accent1"/>
-          </a:fillRef>
-          <a:effectRef idx="2">
-            <a:schemeClr val="accent1"/>
-          </a:effectRef>
-          <a:fontRef idx="minor">
-            <a:schemeClr val="lt1"/>
-          </a:fontRef>
-        </p:style>
-        <p:txBody>
-          <a:bodyPr rtlCol="0" anchor="ctr"/>
-          <a:lstStyle/>
-          <a:p>
-            <a:pPr algn="ctr">
-              <a:defRPr sz="1300" b="1">
-                <a:solidFill>
-                  <a:srgbClr val="FFFFFF"/>
-                </a:solidFill>
-              </a:defRPr>
-            </a:pPr>
-            <a:r>
-              <a:t>工具</a:t>
-            </a:r>
-          </a:p>
-        </p:txBody>
-      </p:sp>
-      <p:sp>
-        <p:nvSpPr>
-          <p:cNvPr id="9" name="TextBox 8"/>
-          <p:cNvSpPr txBox="1"/>
-          <p:nvPr/>
-        </p:nvSpPr>
-        <p:spPr>
-          <a:xfrm>
-            <a:off x="6263640" y="2606040"/>
-            <a:ext cx="2240280" cy="1417320"/>
-          </a:xfrm>
-          <a:prstGeom prst="rect">
-            <a:avLst/>
-          </a:prstGeom>
-          <a:noFill/>
-        </p:spPr>
-        <p:txBody>
-          <a:bodyPr wrap="square">
-            <a:spAutoFit/>
-          </a:bodyPr>
-          <a:lstStyle/>
-          <a:p>
-            <a:pPr>
-              <a:spcAft>
-                <a:spcPts val="800"/>
-              </a:spcAft>
-              <a:defRPr sz="1600">
-                <a:solidFill>
-                  <a:srgbClr val="181F2A"/>
-                </a:solidFill>
-              </a:defRPr>
-            </a:pPr>
-            <a:r>
-              <a:t>调用前授权，调用中约束，调用后审计。</a:t>
-            </a:r>
-          </a:p>
-        </p:txBody>
-      </p:sp>
-      <p:sp>
-        <p:nvSpPr>
-          <p:cNvPr id="10" name="Rounded Rectangle 9"/>
-          <p:cNvSpPr/>
-          <p:nvPr/>
-        </p:nvSpPr>
-        <p:spPr>
-          <a:xfrm>
-            <a:off x="9052559" y="1828800"/>
-            <a:ext cx="2240280" cy="502920"/>
-          </a:xfrm>
-          <a:prstGeom prst="roundRect">
-            <a:avLst/>
-          </a:prstGeom>
-          <a:solidFill>
-            <a:srgbClr val="2463EB"/>
-          </a:solidFill>
-          <a:ln>
-            <a:solidFill>
-              <a:srgbClr val="2463EB"/>
-            </a:solidFill>
-          </a:ln>
-        </p:spPr>
-        <p:style>
-          <a:lnRef idx="1">
-            <a:schemeClr val="accent1"/>
-          </a:lnRef>
-          <a:fillRef idx="3">
-            <a:schemeClr val="accent1"/>
-          </a:fillRef>
-          <a:effectRef idx="2">
-            <a:schemeClr val="accent1"/>
-          </a:effectRef>
-          <a:fontRef idx="minor">
-            <a:schemeClr val="lt1"/>
-          </a:fontRef>
-        </p:style>
-        <p:txBody>
-          <a:bodyPr rtlCol="0" anchor="ctr"/>
-          <a:lstStyle/>
-          <a:p>
-            <a:pPr algn="ctr">
-              <a:defRPr sz="1300" b="1">
-                <a:solidFill>
-                  <a:srgbClr val="FFFFFF"/>
-                </a:solidFill>
-              </a:defRPr>
-            </a:pPr>
-            <a:r>
-              <a:t>产物</a:t>
-            </a:r>
-          </a:p>
-        </p:txBody>
-      </p:sp>
-      <p:sp>
-        <p:nvSpPr>
-          <p:cNvPr id="11" name="TextBox 10"/>
-          <p:cNvSpPr txBox="1"/>
-          <p:nvPr/>
-        </p:nvSpPr>
-        <p:spPr>
-          <a:xfrm>
-            <a:off x="9052559" y="2606040"/>
-            <a:ext cx="2240280" cy="1417320"/>
-          </a:xfrm>
-          <a:prstGeom prst="rect">
-            <a:avLst/>
-          </a:prstGeom>
-          <a:noFill/>
-        </p:spPr>
-        <p:txBody>
-          <a:bodyPr wrap="square">
-            <a:spAutoFit/>
-          </a:bodyPr>
-          <a:lstStyle/>
-          <a:p>
-            <a:pPr>
-              <a:spcAft>
-                <a:spcPts val="800"/>
-              </a:spcAft>
-              <a:defRPr sz="1600">
-                <a:solidFill>
-                  <a:srgbClr val="181F2A"/>
-                </a:solidFill>
-              </a:defRPr>
-            </a:pPr>
-            <a:r>
-              <a:t>结果文件、日志、执行记录归属当前任务。</a:t>
-            </a:r>
-          </a:p>
-        </p:txBody>
-      </p:sp>
-      <p:sp>
-        <p:nvSpPr>
-          <p:cNvPr id="12" name="TextBox 11"/>
-          <p:cNvSpPr txBox="1"/>
-          <p:nvPr/>
-        </p:nvSpPr>
-        <p:spPr>
-          <a:xfrm>
-            <a:off x="777240" y="4572000"/>
-            <a:ext cx="10424160" cy="731520"/>
-          </a:xfrm>
-          <a:prstGeom prst="rect">
-            <a:avLst/>
-          </a:prstGeom>
-          <a:noFill/>
-        </p:spPr>
-        <p:txBody>
-          <a:bodyPr wrap="square">
-            <a:spAutoFit/>
-          </a:bodyPr>
-          <a:lstStyle/>
-          <a:p>
-            <a:pPr>
-              <a:spcAft>
-                <a:spcPts val="800"/>
-              </a:spcAft>
-              <a:defRPr sz="2000">
-                <a:solidFill>
-                  <a:srgbClr val="181F2A"/>
-                </a:solidFill>
-              </a:defRPr>
-            </a:pPr>
-            <a:r>
-              <a:t>结论：安全不只判断“能不能访问”，还要判断“能不能代表用户完成这一步动作”。</a:t>
-            </a:r>
-          </a:p>
-        </p:txBody>
-      </p:sp>
-      <p:sp>
-        <p:nvSpPr>
-          <p:cNvPr id="13" name="TextBox 12"/>
-          <p:cNvSpPr txBox="1"/>
-          <p:nvPr/>
-        </p:nvSpPr>
-        <p:spPr>
-          <a:xfrm>
-            <a:off x="594360" y="6446520"/>
-            <a:ext cx="10972800" cy="228600"/>
-          </a:xfrm>
-          <a:prstGeom prst="rect">
-            <a:avLst/>
-          </a:prstGeom>
-          <a:noFill/>
-        </p:spPr>
-        <p:txBody>
           <a:bodyPr wrap="none">
             <a:spAutoFit/>
           </a:bodyPr>
           <a:lstStyle/>
           <a:p>
-            <a:pPr>
-              <a:defRPr sz="900">
-                <a:solidFill>
-                  <a:srgbClr val="525C6C"/>
-                </a:solidFill>
-              </a:defRPr>
-            </a:pPr>
-            <a:r>
-              <a:t>XWorkmate App 场景测试用例 · AI 安全演进 · 3</a:t>
+            <a:pPr algn="r"/>
+            <a:r>
+              <a:rPr sz="900">
+                <a:solidFill>
+                  <a:srgbClr val="475569"/>
+                </a:solidFill>
+              </a:rPr>
+              <a:t>Question shift</a:t>
             </a:r>
           </a:p>
         </p:txBody>
@@ -4656,8 +3884,8 @@
         </p:nvSpPr>
         <p:spPr>
           <a:xfrm>
-            <a:off x="594360" y="384048"/>
-            <a:ext cx="10972800" cy="685800"/>
+            <a:off x="548640" y="320040"/>
+            <a:ext cx="11064240" cy="731520"/>
           </a:xfrm>
           <a:prstGeom prst="rect">
             <a:avLst/>
@@ -4670,29 +3898,238 @@
           </a:bodyPr>
           <a:lstStyle/>
           <a:p>
+            <a:r>
+              <a:rPr sz="2800" b="1">
+                <a:solidFill>
+                  <a:srgbClr val="0F172A"/>
+                </a:solidFill>
+                <a:latin typeface="PingFang SC"/>
+              </a:rPr>
+              <a:t>当下的安全重点</a:t>
+            </a:r>
+          </a:p>
+        </p:txBody>
+      </p:sp>
+      <p:sp>
+        <p:nvSpPr>
+          <p:cNvPr id="3" name="Rectangle 2"/>
+          <p:cNvSpPr/>
+          <p:nvPr/>
+        </p:nvSpPr>
+        <p:spPr>
+          <a:xfrm>
+            <a:off x="640080" y="1645920"/>
+            <a:ext cx="2926080" cy="2468880"/>
+          </a:xfrm>
+          <a:prstGeom prst="rect">
+            <a:avLst/>
+          </a:prstGeom>
+          <a:solidFill>
+            <a:srgbClr val="FFFFFF"/>
+          </a:solidFill>
+          <a:ln>
+            <a:solidFill>
+              <a:srgbClr val="CBD5E1"/>
+            </a:solidFill>
+          </a:ln>
+        </p:spPr>
+        <p:style>
+          <a:lnRef idx="1">
+            <a:schemeClr val="accent1"/>
+          </a:lnRef>
+          <a:fillRef idx="3">
+            <a:schemeClr val="accent1"/>
+          </a:fillRef>
+          <a:effectRef idx="2">
+            <a:schemeClr val="accent1"/>
+          </a:effectRef>
+          <a:fontRef idx="minor">
+            <a:schemeClr val="lt1"/>
+          </a:fontRef>
+        </p:style>
+        <p:txBody>
+          <a:bodyPr rtlCol="0" anchor="ctr"/>
+          <a:lstStyle/>
+          <a:p>
+            <a:pPr algn="ctr"/>
+            <a:r>
+              <a:rPr sz="1800" b="1">
+                <a:solidFill>
+                  <a:srgbClr val="2563EB"/>
+                </a:solidFill>
+                <a:latin typeface="PingFang SC"/>
+              </a:rPr>
+              <a:t>身份边界</a:t>
+            </a:r>
+          </a:p>
+          <a:p>
             <a:pPr>
-              <a:defRPr sz="3000" b="1">
-                <a:solidFill>
-                  <a:srgbClr val="181F2A"/>
-                </a:solidFill>
-              </a:defRPr>
+              <a:spcBef>
+                <a:spcPts val="1200"/>
+              </a:spcBef>
             </a:pPr>
             <a:r>
-              <a:t>AI Agent 身份：不能复用管理员 token</a:t>
-            </a:r>
-          </a:p>
-        </p:txBody>
-      </p:sp>
-      <p:sp>
-        <p:nvSpPr>
-          <p:cNvPr id="3" name="TextBox 2"/>
+              <a:rPr sz="1300">
+                <a:solidFill>
+                  <a:srgbClr val="0F172A"/>
+                </a:solidFill>
+                <a:latin typeface="PingFang SC"/>
+              </a:rPr>
+              <a:t>人、应用、Agent、工具都要有可区分身份。</a:t>
+            </a:r>
+          </a:p>
+        </p:txBody>
+      </p:sp>
+      <p:sp>
+        <p:nvSpPr>
+          <p:cNvPr id="4" name="Rectangle 3"/>
+          <p:cNvSpPr/>
+          <p:nvPr/>
+        </p:nvSpPr>
+        <p:spPr>
+          <a:xfrm>
+            <a:off x="4069080" y="1645920"/>
+            <a:ext cx="2926080" cy="2468880"/>
+          </a:xfrm>
+          <a:prstGeom prst="rect">
+            <a:avLst/>
+          </a:prstGeom>
+          <a:solidFill>
+            <a:srgbClr val="FFFFFF"/>
+          </a:solidFill>
+          <a:ln>
+            <a:solidFill>
+              <a:srgbClr val="CBD5E1"/>
+            </a:solidFill>
+          </a:ln>
+        </p:spPr>
+        <p:style>
+          <a:lnRef idx="1">
+            <a:schemeClr val="accent1"/>
+          </a:lnRef>
+          <a:fillRef idx="3">
+            <a:schemeClr val="accent1"/>
+          </a:fillRef>
+          <a:effectRef idx="2">
+            <a:schemeClr val="accent1"/>
+          </a:effectRef>
+          <a:fontRef idx="minor">
+            <a:schemeClr val="lt1"/>
+          </a:fontRef>
+        </p:style>
+        <p:txBody>
+          <a:bodyPr rtlCol="0" anchor="ctr"/>
+          <a:lstStyle/>
+          <a:p>
+            <a:pPr algn="ctr"/>
+            <a:r>
+              <a:rPr sz="1800" b="1">
+                <a:solidFill>
+                  <a:srgbClr val="2563EB"/>
+                </a:solidFill>
+                <a:latin typeface="PingFang SC"/>
+              </a:rPr>
+              <a:t>知识边界</a:t>
+            </a:r>
+          </a:p>
+          <a:p>
+            <a:pPr>
+              <a:spcBef>
+                <a:spcPts val="1200"/>
+              </a:spcBef>
+            </a:pPr>
+            <a:r>
+              <a:rPr sz="1300">
+                <a:solidFill>
+                  <a:srgbClr val="0F172A"/>
+                </a:solidFill>
+                <a:latin typeface="PingFang SC"/>
+              </a:rPr>
+              <a:t>RAG、提示词、文件、业务语料按权限进入上下文。</a:t>
+            </a:r>
+          </a:p>
+        </p:txBody>
+      </p:sp>
+      <p:sp>
+        <p:nvSpPr>
+          <p:cNvPr id="5" name="Rectangle 4"/>
+          <p:cNvSpPr/>
+          <p:nvPr/>
+        </p:nvSpPr>
+        <p:spPr>
+          <a:xfrm>
+            <a:off x="7498079" y="1645920"/>
+            <a:ext cx="2926080" cy="2468880"/>
+          </a:xfrm>
+          <a:prstGeom prst="rect">
+            <a:avLst/>
+          </a:prstGeom>
+          <a:solidFill>
+            <a:srgbClr val="FFFFFF"/>
+          </a:solidFill>
+          <a:ln>
+            <a:solidFill>
+              <a:srgbClr val="CBD5E1"/>
+            </a:solidFill>
+          </a:ln>
+        </p:spPr>
+        <p:style>
+          <a:lnRef idx="1">
+            <a:schemeClr val="accent1"/>
+          </a:lnRef>
+          <a:fillRef idx="3">
+            <a:schemeClr val="accent1"/>
+          </a:fillRef>
+          <a:effectRef idx="2">
+            <a:schemeClr val="accent1"/>
+          </a:effectRef>
+          <a:fontRef idx="minor">
+            <a:schemeClr val="lt1"/>
+          </a:fontRef>
+        </p:style>
+        <p:txBody>
+          <a:bodyPr rtlCol="0" anchor="ctr"/>
+          <a:lstStyle/>
+          <a:p>
+            <a:pPr algn="ctr"/>
+            <a:r>
+              <a:rPr sz="1800" b="1">
+                <a:solidFill>
+                  <a:srgbClr val="2563EB"/>
+                </a:solidFill>
+                <a:latin typeface="PingFang SC"/>
+              </a:rPr>
+              <a:t>行动边界</a:t>
+            </a:r>
+          </a:p>
+          <a:p>
+            <a:pPr>
+              <a:spcBef>
+                <a:spcPts val="1200"/>
+              </a:spcBef>
+            </a:pPr>
+            <a:r>
+              <a:rPr sz="1300">
+                <a:solidFill>
+                  <a:srgbClr val="0F172A"/>
+                </a:solidFill>
+                <a:latin typeface="PingFang SC"/>
+              </a:rPr>
+              <a:t>Agent 调工具、改数据、发请求、创建任务都要可授权、可追踪、可撤销。</a:t>
+            </a:r>
+          </a:p>
+        </p:txBody>
+      </p:sp>
+      <p:sp>
+        <p:nvSpPr>
+          <p:cNvPr id="6" name="TextBox 5"/>
           <p:cNvSpPr txBox="1"/>
           <p:nvPr/>
         </p:nvSpPr>
         <p:spPr>
           <a:xfrm>
-            <a:off x="621792" y="1024128"/>
-            <a:ext cx="10789920" cy="384048"/>
+            <a:off x="548640" y="6400800"/>
+            <a:ext cx="11064240" cy="228600"/>
           </a:xfrm>
           <a:prstGeom prst="rect">
             <a:avLst/>
@@ -4705,261 +4142,14 @@
           </a:bodyPr>
           <a:lstStyle/>
           <a:p>
-            <a:pPr>
-              <a:defRPr sz="1400">
-                <a:solidFill>
-                  <a:srgbClr val="525C6C"/>
-                </a:solidFill>
-              </a:defRPr>
-            </a:pPr>
-            <a:r>
-              <a:t>Agent 是任务执行主体，需要独立身份与可撤销授权</a:t>
-            </a:r>
-          </a:p>
-        </p:txBody>
-      </p:sp>
-      <p:sp>
-        <p:nvSpPr>
-          <p:cNvPr id="4" name="TextBox 3"/>
-          <p:cNvSpPr txBox="1"/>
-          <p:nvPr/>
-        </p:nvSpPr>
-        <p:spPr>
-          <a:xfrm>
-            <a:off x="777240" y="1600200"/>
-            <a:ext cx="5029200" cy="4114800"/>
-          </a:xfrm>
-          <a:prstGeom prst="rect">
-            <a:avLst/>
-          </a:prstGeom>
-          <a:noFill/>
-        </p:spPr>
-        <p:txBody>
-          <a:bodyPr wrap="square">
-            <a:spAutoFit/>
-          </a:bodyPr>
-          <a:lstStyle/>
-          <a:p>
-            <a:pPr>
-              <a:spcAft>
-                <a:spcPts val="800"/>
-              </a:spcAft>
-              <a:defRPr sz="2000">
-                <a:solidFill>
-                  <a:srgbClr val="181F2A"/>
-                </a:solidFill>
-              </a:defRPr>
-            </a:pPr>
-            <a:r>
-              <a:t>Agent 代表哪个用户或组织？</a:t>
-            </a:r>
-          </a:p>
-          <a:p>
-            <a:pPr>
-              <a:spcAft>
-                <a:spcPts val="800"/>
-              </a:spcAft>
-              <a:defRPr sz="2000">
-                <a:solidFill>
-                  <a:srgbClr val="181F2A"/>
-                </a:solidFill>
-              </a:defRPr>
-            </a:pPr>
-            <a:r>
-              <a:t>Agent 能访问哪些文件、知识库和项目？</a:t>
-            </a:r>
-          </a:p>
-          <a:p>
-            <a:pPr>
-              <a:spcAft>
-                <a:spcPts val="800"/>
-              </a:spcAft>
-              <a:defRPr sz="2000">
-                <a:solidFill>
-                  <a:srgbClr val="181F2A"/>
-                </a:solidFill>
-              </a:defRPr>
-            </a:pPr>
-            <a:r>
-              <a:t>Agent 能调用哪些工具，参数范围是什么？</a:t>
-            </a:r>
-          </a:p>
-          <a:p>
-            <a:pPr>
-              <a:spcAft>
-                <a:spcPts val="800"/>
-              </a:spcAft>
-              <a:defRPr sz="2000">
-                <a:solidFill>
-                  <a:srgbClr val="181F2A"/>
-                </a:solidFill>
-              </a:defRPr>
-            </a:pPr>
-            <a:r>
-              <a:t>Agent 的动作如何审计到人、任务、工具、结果？</a:t>
-            </a:r>
-          </a:p>
-          <a:p>
-            <a:pPr>
-              <a:spcAft>
-                <a:spcPts val="800"/>
-              </a:spcAft>
-              <a:defRPr sz="2000">
-                <a:solidFill>
-                  <a:srgbClr val="181F2A"/>
-                </a:solidFill>
-              </a:defRPr>
-            </a:pPr>
-            <a:r>
-              <a:t>授权如何过期、撤销和复盘？</a:t>
-            </a:r>
-          </a:p>
-        </p:txBody>
-      </p:sp>
-      <p:sp>
-        <p:nvSpPr>
-          <p:cNvPr id="5" name="TextBox 4"/>
-          <p:cNvSpPr txBox="1"/>
-          <p:nvPr/>
-        </p:nvSpPr>
-        <p:spPr>
-          <a:xfrm>
-            <a:off x="6400800" y="1737360"/>
-            <a:ext cx="4754880" cy="3474720"/>
-          </a:xfrm>
-          <a:prstGeom prst="rect">
-            <a:avLst/>
-          </a:prstGeom>
-          <a:noFill/>
-        </p:spPr>
-        <p:txBody>
-          <a:bodyPr wrap="square">
-            <a:spAutoFit/>
-          </a:bodyPr>
-          <a:lstStyle/>
-          <a:p>
-            <a:pPr>
-              <a:spcAft>
-                <a:spcPts val="800"/>
-              </a:spcAft>
-              <a:defRPr sz="1800">
-                <a:solidFill>
-                  <a:srgbClr val="181F2A"/>
-                </a:solidFill>
-              </a:defRPr>
-            </a:pPr>
-            <a:r>
-              <a:t>设计原则</a:t>
-            </a:r>
-          </a:p>
-          <a:p>
-            <a:pPr>
-              <a:spcAft>
-                <a:spcPts val="800"/>
-              </a:spcAft>
-              <a:defRPr sz="1800">
-                <a:solidFill>
-                  <a:srgbClr val="181F2A"/>
-                </a:solidFill>
-              </a:defRPr>
-            </a:pPr>
-            <a:r>
-              <a:t>独立主体身份</a:t>
-            </a:r>
-          </a:p>
-          <a:p>
-            <a:pPr>
-              <a:spcAft>
-                <a:spcPts val="800"/>
-              </a:spcAft>
-              <a:defRPr sz="1800">
-                <a:solidFill>
-                  <a:srgbClr val="181F2A"/>
-                </a:solidFill>
-              </a:defRPr>
-            </a:pPr>
-            <a:r>
-              <a:t>最小权限授权</a:t>
-            </a:r>
-          </a:p>
-          <a:p>
-            <a:pPr>
-              <a:spcAft>
-                <a:spcPts val="800"/>
-              </a:spcAft>
-              <a:defRPr sz="1800">
-                <a:solidFill>
-                  <a:srgbClr val="181F2A"/>
-                </a:solidFill>
-              </a:defRPr>
-            </a:pPr>
-            <a:r>
-              <a:t>按任务绑定上下文</a:t>
-            </a:r>
-          </a:p>
-          <a:p>
-            <a:pPr>
-              <a:spcAft>
-                <a:spcPts val="800"/>
-              </a:spcAft>
-              <a:defRPr sz="1800">
-                <a:solidFill>
-                  <a:srgbClr val="181F2A"/>
-                </a:solidFill>
-              </a:defRPr>
-            </a:pPr>
-            <a:r>
-              <a:t>全过程审计</a:t>
-            </a:r>
-          </a:p>
-          <a:p>
-            <a:pPr>
-              <a:spcAft>
-                <a:spcPts val="800"/>
-              </a:spcAft>
-              <a:defRPr sz="1800">
-                <a:solidFill>
-                  <a:srgbClr val="181F2A"/>
-                </a:solidFill>
-              </a:defRPr>
-            </a:pPr>
-            <a:r>
-              <a:t>失败可重试，风险可止损</a:t>
-            </a:r>
-          </a:p>
-        </p:txBody>
-      </p:sp>
-      <p:sp>
-        <p:nvSpPr>
-          <p:cNvPr id="6" name="TextBox 5"/>
-          <p:cNvSpPr txBox="1"/>
-          <p:nvPr/>
-        </p:nvSpPr>
-        <p:spPr>
-          <a:xfrm>
-            <a:off x="594360" y="6446520"/>
-            <a:ext cx="10972800" cy="228600"/>
-          </a:xfrm>
-          <a:prstGeom prst="rect">
-            <a:avLst/>
-          </a:prstGeom>
-          <a:noFill/>
-        </p:spPr>
-        <p:txBody>
-          <a:bodyPr wrap="none">
-            <a:spAutoFit/>
-          </a:bodyPr>
-          <a:lstStyle/>
-          <a:p>
-            <a:pPr>
-              <a:defRPr sz="900">
-                <a:solidFill>
-                  <a:srgbClr val="525C6C"/>
-                </a:solidFill>
-              </a:defRPr>
-            </a:pPr>
-            <a:r>
-              <a:t>XWorkmate App 场景测试用例 · AI 安全演进 · 4</a:t>
+            <a:pPr algn="r"/>
+            <a:r>
+              <a:rPr sz="900">
+                <a:solidFill>
+                  <a:srgbClr val="475569"/>
+                </a:solidFill>
+              </a:rPr>
+              <a:t>Three control planes</a:t>
             </a:r>
           </a:p>
         </p:txBody>
@@ -4998,8 +4188,8 @@
         </p:nvSpPr>
         <p:spPr>
           <a:xfrm>
-            <a:off x="594360" y="384048"/>
-            <a:ext cx="10972800" cy="685800"/>
+            <a:off x="548640" y="320040"/>
+            <a:ext cx="11064240" cy="731520"/>
           </a:xfrm>
           <a:prstGeom prst="rect">
             <a:avLst/>
@@ -5012,15 +4202,14 @@
           </a:bodyPr>
           <a:lstStyle/>
           <a:p>
-            <a:pPr>
-              <a:defRPr sz="3000" b="1">
-                <a:solidFill>
-                  <a:srgbClr val="181F2A"/>
-                </a:solidFill>
-              </a:defRPr>
-            </a:pPr>
-            <a:r>
-              <a:t>模型与知识保护：新资产边界</a:t>
+            <a:r>
+              <a:rPr sz="2800" b="1">
+                <a:solidFill>
+                  <a:srgbClr val="0F172A"/>
+                </a:solidFill>
+                <a:latin typeface="PingFang SC"/>
+              </a:rPr>
+              <a:t>结语</a:t>
             </a:r>
           </a:p>
         </p:txBody>
@@ -5033,8 +4222,8 @@
         </p:nvSpPr>
         <p:spPr>
           <a:xfrm>
-            <a:off x="621792" y="1024128"/>
-            <a:ext cx="10789920" cy="384048"/>
+            <a:off x="685800" y="1325880"/>
+            <a:ext cx="10698480" cy="3200400"/>
           </a:xfrm>
           <a:prstGeom prst="rect">
             <a:avLst/>
@@ -5048,14 +4237,50 @@
           <a:lstStyle/>
           <a:p>
             <a:pPr>
-              <a:defRPr sz="1400">
-                <a:solidFill>
-                  <a:srgbClr val="525C6C"/>
-                </a:solidFill>
-              </a:defRPr>
+              <a:spcAft>
+                <a:spcPts val="1200"/>
+              </a:spcAft>
             </a:pPr>
             <a:r>
-              <a:t>企业知识不只在数据库里，也在提示词、RAG、工具记录和上下文里</a:t>
+              <a:rPr sz="2400" b="0">
+                <a:solidFill>
+                  <a:srgbClr val="0F172A"/>
+                </a:solidFill>
+                <a:latin typeface="PingFang SC"/>
+              </a:rPr>
+              <a:t>安全已经从“谁能访问系统”升级为“谁能携带什么知识，以什么身份，替谁执行什么动作”。</a:t>
+            </a:r>
+          </a:p>
+          <a:p>
+            <a:pPr>
+              <a:spcAft>
+                <a:spcPts val="1200"/>
+              </a:spcAft>
+            </a:pPr>
+            <a:r>
+              <a:rPr sz="2000" b="0">
+                <a:solidFill>
+                  <a:srgbClr val="0F172A"/>
+                </a:solidFill>
+                <a:latin typeface="PingFang SC"/>
+              </a:rPr>
+              <a:t/>
+            </a:r>
+          </a:p>
+          <a:p>
+            <a:pPr>
+              <a:spcAft>
+                <a:spcPts val="1200"/>
+              </a:spcAft>
+            </a:pPr>
+            <a:r>
+              <a:rPr sz="2000" b="1">
+                <a:solidFill>
+                  <a:srgbClr val="0F172A"/>
+                </a:solidFill>
+                <a:latin typeface="PingFang SC"/>
+              </a:rPr>
+              <a:t>这就是 AI 时代的边界迁移。</a:t>
             </a:r>
           </a:p>
         </p:txBody>
@@ -5068,8 +4293,8 @@
         </p:nvSpPr>
         <p:spPr>
           <a:xfrm>
-            <a:off x="822960" y="1645920"/>
-            <a:ext cx="10424160" cy="4389120"/>
+            <a:off x="548640" y="6400800"/>
+            <a:ext cx="11064240" cy="228600"/>
           </a:xfrm>
           <a:prstGeom prst="rect">
             <a:avLst/>
@@ -5077,347 +4302,19 @@
           <a:noFill/>
         </p:spPr>
         <p:txBody>
-          <a:bodyPr wrap="square">
-            <a:spAutoFit/>
-          </a:bodyPr>
-          <a:lstStyle/>
-          <a:p>
-            <a:pPr>
-              <a:spcAft>
-                <a:spcPts val="800"/>
-              </a:spcAft>
-              <a:defRPr sz="1900">
-                <a:solidFill>
-                  <a:srgbClr val="181F2A"/>
-                </a:solidFill>
-              </a:defRPr>
-            </a:pPr>
-            <a:r>
-              <a:t>提示词与系统指令：定义 Agent 行为边界，不能被随意覆盖或泄露。</a:t>
-            </a:r>
-          </a:p>
-          <a:p>
-            <a:pPr>
-              <a:spcAft>
-                <a:spcPts val="800"/>
-              </a:spcAft>
-              <a:defRPr sz="1900">
-                <a:solidFill>
-                  <a:srgbClr val="181F2A"/>
-                </a:solidFill>
-              </a:defRPr>
-            </a:pPr>
-            <a:r>
-              <a:t>RAG 知识库：必须按组织、项目、用户和任务做权限过滤。</a:t>
-            </a:r>
-          </a:p>
-          <a:p>
-            <a:pPr>
-              <a:spcAft>
-                <a:spcPts val="800"/>
-              </a:spcAft>
-              <a:defRPr sz="1900">
-                <a:solidFill>
-                  <a:srgbClr val="181F2A"/>
-                </a:solidFill>
-              </a:defRPr>
-            </a:pPr>
-            <a:r>
-              <a:t>工具调用记录：包含业务动作、参数、外部系统响应和潜在敏感数据。</a:t>
-            </a:r>
-          </a:p>
-          <a:p>
-            <a:pPr>
-              <a:spcAft>
-                <a:spcPts val="800"/>
-              </a:spcAft>
-              <a:defRPr sz="1900">
-                <a:solidFill>
-                  <a:srgbClr val="181F2A"/>
-                </a:solidFill>
-              </a:defRPr>
-            </a:pPr>
-            <a:r>
-              <a:t>用户上传文件：必须用户驱动访问，不能被 Agent 隐式读取和转发。</a:t>
-            </a:r>
-          </a:p>
-          <a:p>
-            <a:pPr>
-              <a:spcAft>
-                <a:spcPts val="800"/>
-              </a:spcAft>
-              <a:defRPr sz="1900">
-                <a:solidFill>
-                  <a:srgbClr val="181F2A"/>
-                </a:solidFill>
-              </a:defRPr>
-            </a:pPr>
-            <a:r>
-              <a:t>业务语料：进入上下文就意味着进入执行链路，需要审计和保留策略。</a:t>
-            </a:r>
-          </a:p>
-        </p:txBody>
-      </p:sp>
-      <p:sp>
-        <p:nvSpPr>
-          <p:cNvPr id="5" name="TextBox 4"/>
-          <p:cNvSpPr txBox="1"/>
-          <p:nvPr/>
-        </p:nvSpPr>
-        <p:spPr>
-          <a:xfrm>
-            <a:off x="594360" y="6446520"/>
-            <a:ext cx="10972800" cy="228600"/>
-          </a:xfrm>
-          <a:prstGeom prst="rect">
-            <a:avLst/>
-          </a:prstGeom>
-          <a:noFill/>
-        </p:spPr>
-        <p:txBody>
           <a:bodyPr wrap="none">
             <a:spAutoFit/>
           </a:bodyPr>
           <a:lstStyle/>
           <a:p>
-            <a:pPr>
-              <a:defRPr sz="900">
-                <a:solidFill>
-                  <a:srgbClr val="525C6C"/>
-                </a:solidFill>
-              </a:defRPr>
-            </a:pPr>
-            <a:r>
-              <a:t>XWorkmate App 场景测试用例 · AI 安全演进 · 5</a:t>
-            </a:r>
-          </a:p>
-        </p:txBody>
-      </p:sp>
-    </p:spTree>
-  </p:cSld>
-  <p:clrMapOvr>
-    <a:masterClrMapping/>
-  </p:clrMapOvr>
-</p:sld>
-</file>
-
-<file path=ppt/slides/slide6.xml><?xml version="1.0" encoding="utf-8"?>
-<p:sld xmlns:a="http://schemas.openxmlformats.org/drawingml/2006/main" xmlns:p="http://schemas.openxmlformats.org/presentationml/2006/main" xmlns:r="http://schemas.openxmlformats.org/officeDocument/2006/relationships">
-  <p:cSld>
-    <p:bg>
-      <p:bgPr>
-        <a:solidFill>
-          <a:srgbClr val="F8FAFC"/>
-        </a:solidFill>
-        <a:effectLst/>
-      </p:bgPr>
-    </p:bg>
-    <p:spTree>
-      <p:nvGrpSpPr>
-        <p:cNvPr id="1" name=""/>
-        <p:cNvGrpSpPr/>
-        <p:nvPr/>
-      </p:nvGrpSpPr>
-      <p:grpSpPr/>
-      <p:sp>
-        <p:nvSpPr>
-          <p:cNvPr id="2" name="TextBox 1"/>
-          <p:cNvSpPr txBox="1"/>
-          <p:nvPr/>
-        </p:nvSpPr>
-        <p:spPr>
-          <a:xfrm>
-            <a:off x="594360" y="384048"/>
-            <a:ext cx="10972800" cy="685800"/>
-          </a:xfrm>
-          <a:prstGeom prst="rect">
-            <a:avLst/>
-          </a:prstGeom>
-          <a:noFill/>
-        </p:spPr>
-        <p:txBody>
-          <a:bodyPr wrap="none">
-            <a:spAutoFit/>
-          </a:bodyPr>
-          <a:lstStyle/>
-          <a:p>
-            <a:pPr>
-              <a:defRPr sz="3000" b="1">
-                <a:solidFill>
-                  <a:srgbClr val="181F2A"/>
-                </a:solidFill>
-              </a:defRPr>
-            </a:pPr>
-            <a:r>
-              <a:t>落地行动清单</a:t>
-            </a:r>
-          </a:p>
-        </p:txBody>
-      </p:sp>
-      <p:sp>
-        <p:nvSpPr>
-          <p:cNvPr id="3" name="TextBox 2"/>
-          <p:cNvSpPr txBox="1"/>
-          <p:nvPr/>
-        </p:nvSpPr>
-        <p:spPr>
-          <a:xfrm>
-            <a:off x="621792" y="1024128"/>
-            <a:ext cx="10789920" cy="384048"/>
-          </a:xfrm>
-          <a:prstGeom prst="rect">
-            <a:avLst/>
-          </a:prstGeom>
-          <a:noFill/>
-        </p:spPr>
-        <p:txBody>
-          <a:bodyPr wrap="none">
-            <a:spAutoFit/>
-          </a:bodyPr>
-          <a:lstStyle/>
-          <a:p>
-            <a:pPr>
-              <a:defRPr sz="1400">
-                <a:solidFill>
-                  <a:srgbClr val="525C6C"/>
-                </a:solidFill>
-              </a:defRPr>
-            </a:pPr>
-            <a:r>
-              <a:t>把 AI 安全从提示词治理推进到运行时治理</a:t>
-            </a:r>
-          </a:p>
-        </p:txBody>
-      </p:sp>
-      <p:sp>
-        <p:nvSpPr>
-          <p:cNvPr id="4" name="TextBox 3"/>
-          <p:cNvSpPr txBox="1"/>
-          <p:nvPr/>
-        </p:nvSpPr>
-        <p:spPr>
-          <a:xfrm>
-            <a:off x="777240" y="1600200"/>
-            <a:ext cx="10607040" cy="4434840"/>
-          </a:xfrm>
-          <a:prstGeom prst="rect">
-            <a:avLst/>
-          </a:prstGeom>
-          <a:noFill/>
-        </p:spPr>
-        <p:txBody>
-          <a:bodyPr wrap="square">
-            <a:spAutoFit/>
-          </a:bodyPr>
-          <a:lstStyle/>
-          <a:p>
-            <a:pPr>
-              <a:spcAft>
-                <a:spcPts val="800"/>
-              </a:spcAft>
-              <a:defRPr sz="2000">
-                <a:solidFill>
-                  <a:srgbClr val="181F2A"/>
-                </a:solidFill>
-              </a:defRPr>
-            </a:pPr>
-            <a:r>
-              <a:t>建立 Agent 身份模型：人、应用、Agent、工具、服务账号分开审计。</a:t>
-            </a:r>
-          </a:p>
-          <a:p>
-            <a:pPr>
-              <a:spcAft>
-                <a:spcPts val="800"/>
-              </a:spcAft>
-              <a:defRPr sz="2000">
-                <a:solidFill>
-                  <a:srgbClr val="181F2A"/>
-                </a:solidFill>
-              </a:defRPr>
-            </a:pPr>
-            <a:r>
-              <a:t>建立知识访问控制：RAG 和文件上下文按任务授权，不做全局默认读取。</a:t>
-            </a:r>
-          </a:p>
-          <a:p>
-            <a:pPr>
-              <a:spcAft>
-                <a:spcPts val="800"/>
-              </a:spcAft>
-              <a:defRPr sz="2000">
-                <a:solidFill>
-                  <a:srgbClr val="181F2A"/>
-                </a:solidFill>
-              </a:defRPr>
-            </a:pPr>
-            <a:r>
-              <a:t>建立工具调用边界：高风险动作增加审批、参数约束和结果确认。</a:t>
-            </a:r>
-          </a:p>
-          <a:p>
-            <a:pPr>
-              <a:spcAft>
-                <a:spcPts val="800"/>
-              </a:spcAft>
-              <a:defRPr sz="2000">
-                <a:solidFill>
-                  <a:srgbClr val="181F2A"/>
-                </a:solidFill>
-              </a:defRPr>
-            </a:pPr>
-            <a:r>
-              <a:t>建立运行时审计链：记录用户意图、Agent 计划、工具调用、产物路径。</a:t>
-            </a:r>
-          </a:p>
-          <a:p>
-            <a:pPr>
-              <a:spcAft>
-                <a:spcPts val="800"/>
-              </a:spcAft>
-              <a:defRPr sz="2000">
-                <a:solidFill>
-                  <a:srgbClr val="181F2A"/>
-                </a:solidFill>
-              </a:defRPr>
-            </a:pPr>
-            <a:r>
-              <a:t>建立撤销与复盘机制：权限可过期，任务可停止，产物可追溯。</a:t>
-            </a:r>
-          </a:p>
-        </p:txBody>
-      </p:sp>
-      <p:sp>
-        <p:nvSpPr>
-          <p:cNvPr id="5" name="TextBox 4"/>
-          <p:cNvSpPr txBox="1"/>
-          <p:nvPr/>
-        </p:nvSpPr>
-        <p:spPr>
-          <a:xfrm>
-            <a:off x="594360" y="6446520"/>
-            <a:ext cx="10972800" cy="228600"/>
-          </a:xfrm>
-          <a:prstGeom prst="rect">
-            <a:avLst/>
-          </a:prstGeom>
-          <a:noFill/>
-        </p:spPr>
-        <p:txBody>
-          <a:bodyPr wrap="none">
-            <a:spAutoFit/>
-          </a:bodyPr>
-          <a:lstStyle/>
-          <a:p>
-            <a:pPr>
-              <a:defRPr sz="900">
-                <a:solidFill>
-                  <a:srgbClr val="525C6C"/>
-                </a:solidFill>
-              </a:defRPr>
-            </a:pPr>
-            <a:r>
-              <a:t>XWorkmate App 场景测试用例 · AI 安全演进 · 6</a:t>
+            <a:pPr algn="r"/>
+            <a:r>
+              <a:rPr sz="900">
+                <a:solidFill>
+                  <a:srgbClr val="475569"/>
+                </a:solidFill>
+              </a:rPr>
+              <a:t>Closing</a:t>
             </a:r>
           </a:p>
         </p:txBody>

</xml_diff>